<commit_message>
figures for zenn article 8d7fea5568e638: describe EFA GDA per the roadmap
</commit_message>
<xml_diff>
--- a/zenn/articles/8d7fea5568e638/source/gin-figures.pptx
+++ b/zenn/articles/8d7fea5568e638/source/gin-figures.pptx
@@ -2891,52 +2891,15 @@
           </a:p>
         </p:txBody>
       </p:sp>
-      <p:cxnSp>
-        <p:nvCxnSpPr>
-          <p:cNvPr id="7" name="Connector 6"/>
-          <p:cNvCxnSpPr/>
-          <p:nvPr/>
-        </p:nvCxnSpPr>
-        <p:spPr>
-          <a:xfrm>
-            <a:off x="6096000" y="2190750"/>
-            <a:ext cx="0" cy="381000"/>
-          </a:xfrm>
-          <a:prstGeom prst="line">
-            <a:avLst/>
-          </a:prstGeom>
-          <a:ln w="25400">
-            <a:solidFill>
-              <a:srgbClr val="F5F5F8"/>
-            </a:solidFill>
-            <a:tailEnd type="triangle" w="med" len="med"/>
-          </a:ln>
-          <a:effectLst/>
-        </p:spPr>
-        <p:style>
-          <a:lnRef idx="2">
-            <a:schemeClr val="accent1"/>
-          </a:lnRef>
-          <a:fillRef idx="0">
-            <a:schemeClr val="accent1"/>
-          </a:fillRef>
-          <a:effectRef idx="1">
-            <a:schemeClr val="accent1"/>
-          </a:effectRef>
-          <a:fontRef idx="minor">
-            <a:schemeClr val="tx1"/>
-          </a:fontRef>
-        </p:style>
-      </p:cxnSp>
-      <p:sp>
-        <p:nvSpPr>
-          <p:cNvPr id="8" name="Rounded Rectangle 7"/>
+      <p:sp>
+        <p:nvSpPr>
+          <p:cNvPr id="7" name="Rounded Rectangle 6"/>
           <p:cNvSpPr/>
           <p:nvPr/>
         </p:nvSpPr>
         <p:spPr>
           <a:xfrm>
-            <a:off x="409575" y="2571750"/>
+            <a:off x="409575" y="2762250"/>
             <a:ext cx="11372850" cy="1905000"/>
           </a:xfrm>
           <a:prstGeom prst="roundRect">
@@ -2978,13 +2941,13 @@
       </p:sp>
       <p:sp>
         <p:nvSpPr>
-          <p:cNvPr id="9" name="TextBox 8"/>
+          <p:cNvPr id="8" name="TextBox 7"/>
           <p:cNvSpPr txBox="1"/>
           <p:nvPr/>
         </p:nvSpPr>
         <p:spPr>
           <a:xfrm>
-            <a:off x="600075" y="2647950"/>
+            <a:off x="600075" y="2819400"/>
             <a:ext cx="3810000" cy="285750"/>
           </a:xfrm>
           <a:prstGeom prst="rect">
@@ -3019,13 +2982,13 @@
       </p:sp>
       <p:sp>
         <p:nvSpPr>
-          <p:cNvPr id="10" name="Rounded Rectangle 9"/>
+          <p:cNvPr id="9" name="Rounded Rectangle 8"/>
           <p:cNvSpPr/>
           <p:nvPr/>
         </p:nvSpPr>
         <p:spPr>
           <a:xfrm>
-            <a:off x="695325" y="3048000"/>
+            <a:off x="695325" y="3143250"/>
             <a:ext cx="3429000" cy="1238250"/>
           </a:xfrm>
           <a:prstGeom prst="roundRect">
@@ -3118,13 +3081,13 @@
       </p:sp>
       <p:sp>
         <p:nvSpPr>
-          <p:cNvPr id="11" name="Rounded Rectangle 10"/>
+          <p:cNvPr id="10" name="Rounded Rectangle 9"/>
           <p:cNvSpPr/>
           <p:nvPr/>
         </p:nvSpPr>
         <p:spPr>
           <a:xfrm>
-            <a:off x="4371975" y="3048000"/>
+            <a:off x="4371975" y="3143250"/>
             <a:ext cx="3429000" cy="1238250"/>
           </a:xfrm>
           <a:prstGeom prst="roundRect">
@@ -3217,13 +3180,13 @@
       </p:sp>
       <p:sp>
         <p:nvSpPr>
-          <p:cNvPr id="12" name="Rounded Rectangle 11"/>
+          <p:cNvPr id="11" name="Rounded Rectangle 10"/>
           <p:cNvSpPr/>
           <p:nvPr/>
         </p:nvSpPr>
         <p:spPr>
           <a:xfrm>
-            <a:off x="8048625" y="3048000"/>
+            <a:off x="8048625" y="3143250"/>
             <a:ext cx="3448050" cy="1238250"/>
           </a:xfrm>
           <a:prstGeom prst="roundRect">
@@ -3309,21 +3272,21 @@
                 <a:ea typeface="メイリオ"/>
                 <a:cs typeface="メイリオ"/>
               </a:rPr>
-              <a:t>EFA, NCCL 2.31.2+</a:t>
+              <a:t>EFA, NCCL 2.31</a:t>
             </a:r>
           </a:p>
         </p:txBody>
       </p:sp>
       <p:cxnSp>
         <p:nvCxnSpPr>
-          <p:cNvPr id="13" name="Connector 12"/>
+          <p:cNvPr id="12" name="Connector 11"/>
           <p:cNvCxnSpPr/>
           <p:nvPr/>
         </p:nvCxnSpPr>
         <p:spPr>
           <a:xfrm>
-            <a:off x="6096000" y="4476750"/>
-            <a:ext cx="0" cy="381000"/>
+            <a:off x="2409825" y="2190750"/>
+            <a:ext cx="0" cy="952500"/>
           </a:xfrm>
           <a:prstGeom prst="line">
             <a:avLst/>
@@ -3351,16 +3314,201 @@
           </a:fontRef>
         </p:style>
       </p:cxnSp>
-      <p:sp>
-        <p:nvSpPr>
-          <p:cNvPr id="14" name="Rounded Rectangle 13"/>
+      <p:cxnSp>
+        <p:nvCxnSpPr>
+          <p:cNvPr id="13" name="Connector 12"/>
+          <p:cNvCxnSpPr/>
+          <p:nvPr/>
+        </p:nvCxnSpPr>
+        <p:spPr>
+          <a:xfrm>
+            <a:off x="6086475" y="2190750"/>
+            <a:ext cx="0" cy="952500"/>
+          </a:xfrm>
+          <a:prstGeom prst="line">
+            <a:avLst/>
+          </a:prstGeom>
+          <a:ln w="25400">
+            <a:solidFill>
+              <a:srgbClr val="2896F0"/>
+            </a:solidFill>
+            <a:tailEnd type="triangle" w="med" len="med"/>
+          </a:ln>
+          <a:effectLst/>
+        </p:spPr>
+        <p:style>
+          <a:lnRef idx="2">
+            <a:schemeClr val="accent1"/>
+          </a:lnRef>
+          <a:fillRef idx="0">
+            <a:schemeClr val="accent1"/>
+          </a:fillRef>
+          <a:effectRef idx="1">
+            <a:schemeClr val="accent1"/>
+          </a:effectRef>
+          <a:fontRef idx="minor">
+            <a:schemeClr val="tx1"/>
+          </a:fontRef>
+        </p:style>
+      </p:cxnSp>
+      <p:cxnSp>
+        <p:nvCxnSpPr>
+          <p:cNvPr id="14" name="Connector 13"/>
+          <p:cNvCxnSpPr/>
+          <p:nvPr/>
+        </p:nvCxnSpPr>
+        <p:spPr>
+          <a:xfrm>
+            <a:off x="9772650" y="2190750"/>
+            <a:ext cx="0" cy="952500"/>
+          </a:xfrm>
+          <a:prstGeom prst="line">
+            <a:avLst/>
+          </a:prstGeom>
+          <a:ln w="25400">
+            <a:solidFill>
+              <a:srgbClr val="F5F5F8"/>
+            </a:solidFill>
+            <a:tailEnd type="triangle" w="med" len="med"/>
+          </a:ln>
+          <a:effectLst/>
+        </p:spPr>
+        <p:style>
+          <a:lnRef idx="2">
+            <a:schemeClr val="accent1"/>
+          </a:lnRef>
+          <a:fillRef idx="0">
+            <a:schemeClr val="accent1"/>
+          </a:fillRef>
+          <a:effectRef idx="1">
+            <a:schemeClr val="accent1"/>
+          </a:effectRef>
+          <a:fontRef idx="minor">
+            <a:schemeClr val="tx1"/>
+          </a:fontRef>
+        </p:style>
+      </p:cxnSp>
+      <p:cxnSp>
+        <p:nvCxnSpPr>
+          <p:cNvPr id="15" name="Connector 14"/>
+          <p:cNvCxnSpPr/>
+          <p:nvPr/>
+        </p:nvCxnSpPr>
+        <p:spPr>
+          <a:xfrm>
+            <a:off x="2409825" y="4381500"/>
+            <a:ext cx="0" cy="1181100"/>
+          </a:xfrm>
+          <a:prstGeom prst="line">
+            <a:avLst/>
+          </a:prstGeom>
+          <a:ln w="25400">
+            <a:solidFill>
+              <a:srgbClr val="F5F5F8"/>
+            </a:solidFill>
+            <a:tailEnd type="triangle" w="med" len="med"/>
+          </a:ln>
+          <a:effectLst/>
+        </p:spPr>
+        <p:style>
+          <a:lnRef idx="2">
+            <a:schemeClr val="accent1"/>
+          </a:lnRef>
+          <a:fillRef idx="0">
+            <a:schemeClr val="accent1"/>
+          </a:fillRef>
+          <a:effectRef idx="1">
+            <a:schemeClr val="accent1"/>
+          </a:effectRef>
+          <a:fontRef idx="minor">
+            <a:schemeClr val="tx1"/>
+          </a:fontRef>
+        </p:style>
+      </p:cxnSp>
+      <p:cxnSp>
+        <p:nvCxnSpPr>
+          <p:cNvPr id="16" name="Connector 15"/>
+          <p:cNvCxnSpPr/>
+          <p:nvPr/>
+        </p:nvCxnSpPr>
+        <p:spPr>
+          <a:xfrm>
+            <a:off x="6086475" y="4381500"/>
+            <a:ext cx="0" cy="1181100"/>
+          </a:xfrm>
+          <a:prstGeom prst="line">
+            <a:avLst/>
+          </a:prstGeom>
+          <a:ln w="25400">
+            <a:solidFill>
+              <a:srgbClr val="2896F0"/>
+            </a:solidFill>
+            <a:tailEnd type="triangle" w="med" len="med"/>
+          </a:ln>
+          <a:effectLst/>
+        </p:spPr>
+        <p:style>
+          <a:lnRef idx="2">
+            <a:schemeClr val="accent1"/>
+          </a:lnRef>
+          <a:fillRef idx="0">
+            <a:schemeClr val="accent1"/>
+          </a:fillRef>
+          <a:effectRef idx="1">
+            <a:schemeClr val="accent1"/>
+          </a:effectRef>
+          <a:fontRef idx="minor">
+            <a:schemeClr val="tx1"/>
+          </a:fontRef>
+        </p:style>
+      </p:cxnSp>
+      <p:cxnSp>
+        <p:nvCxnSpPr>
+          <p:cNvPr id="17" name="Connector 16"/>
+          <p:cNvCxnSpPr/>
+          <p:nvPr/>
+        </p:nvCxnSpPr>
+        <p:spPr>
+          <a:xfrm>
+            <a:off x="9772650" y="4381500"/>
+            <a:ext cx="0" cy="1181100"/>
+          </a:xfrm>
+          <a:prstGeom prst="line">
+            <a:avLst/>
+          </a:prstGeom>
+          <a:ln w="25400">
+            <a:solidFill>
+              <a:srgbClr val="F5F5F8"/>
+            </a:solidFill>
+            <a:tailEnd type="triangle" w="med" len="med"/>
+          </a:ln>
+          <a:effectLst/>
+        </p:spPr>
+        <p:style>
+          <a:lnRef idx="2">
+            <a:schemeClr val="accent1"/>
+          </a:lnRef>
+          <a:fillRef idx="0">
+            <a:schemeClr val="accent1"/>
+          </a:fillRef>
+          <a:effectRef idx="1">
+            <a:schemeClr val="accent1"/>
+          </a:effectRef>
+          <a:fontRef idx="minor">
+            <a:schemeClr val="tx1"/>
+          </a:fontRef>
+        </p:style>
+      </p:cxnSp>
+      <p:sp>
+        <p:nvSpPr>
+          <p:cNvPr id="18" name="Rounded Rectangle 17"/>
           <p:cNvSpPr/>
           <p:nvPr/>
         </p:nvSpPr>
         <p:spPr>
           <a:xfrm>
-            <a:off x="409575" y="4857750"/>
-            <a:ext cx="11372850" cy="762000"/>
+            <a:off x="409575" y="5562600"/>
+            <a:ext cx="11372850" cy="666750"/>
           </a:xfrm>
           <a:prstGeom prst="roundRect">
             <a:avLst>
@@ -4070,7 +4218,7 @@
                 <a:ea typeface="メイリオ"/>
                 <a:cs typeface="メイリオ"/>
               </a:rPr>
-              <a:t>Green / blue: NCCL GIN.  Grey: NVSHMEM</a:t>
+              <a:t>Green: GIN GDAKI (GPU path).  Blue: GIN Proxy (CPU on the path).  Grey: NVSHMEM</a:t>
             </a:r>
           </a:p>
         </p:txBody>
@@ -4129,7 +4277,7 @@
                 <a:ea typeface="メイリオ"/>
                 <a:cs typeface="メイリオ"/>
               </a:rPr>
-              <a:t>GIN on AWS EFA: two modes</a:t>
+              <a:t>GIN on AWS EFA: proxy path and EFA GDA</a:t>
             </a:r>
           </a:p>
         </p:txBody>
@@ -4170,7 +4318,7 @@
                 <a:ea typeface="メイリオ"/>
                 <a:cs typeface="メイリオ"/>
               </a:rPr>
-              <a:t>Green: GPU.  Blue: CPU on the path.  Yellow: EFA.  Grey: requirements</a:t>
+              <a:t>Green: GPU.  Blue: CPU on the path.  Yellow: EFA</a:t>
             </a:r>
           </a:p>
         </p:txBody>
@@ -4211,7 +4359,7 @@
                 <a:ea typeface="メイリオ"/>
                 <a:cs typeface="メイリオ"/>
               </a:rPr>
-              <a:t>Host-proxy mode</a:t>
+              <a:t>GIN proxy (aws-ofi-nccl)</a:t>
             </a:r>
           </a:p>
         </p:txBody>
@@ -4252,7 +4400,7 @@
                 <a:ea typeface="メイリオ"/>
                 <a:cs typeface="メイリオ"/>
               </a:rPr>
-              <a:t>CPU proxy thread in aws-ofi-nccl</a:t>
+              <a:t>CPU proxy thread issues ops</a:t>
             </a:r>
           </a:p>
         </p:txBody>
@@ -4341,7 +4489,7 @@
                 <a:ea typeface="メイリオ"/>
                 <a:cs typeface="メイリオ"/>
               </a:rPr>
-              <a:t>Kernel backend (EFA GDA)</a:t>
+              <a:t>NCCL_GIN_TYPE_EFA_GDA</a:t>
             </a:r>
           </a:p>
         </p:txBody>
@@ -4382,7 +4530,7 @@
                 <a:ea typeface="メイリオ"/>
                 <a:cs typeface="メイリオ"/>
               </a:rPr>
-              <a:t>GPU builds the WQE, rings the doorbell</a:t>
+              <a:t>GPU kernel issues Put / Signal / Flush</a:t>
             </a:r>
           </a:p>
         </p:txBody>
@@ -4493,7 +4641,7 @@
                 <a:ea typeface="メイリオ"/>
                 <a:cs typeface="メイリオ"/>
               </a:rPr>
-              <a:t>GPU kernel: put / signal</a:t>
+              <a:t>GPU kernel (ncclGin)</a:t>
             </a:r>
           </a:p>
         </p:txBody>
@@ -4756,7 +4904,7 @@
                 <a:ea typeface="メイリオ"/>
                 <a:cs typeface="メイリオ"/>
               </a:rPr>
-              <a:t>GPU kernel: put / signal / flush</a:t>
+              <a:t>GPU kernel (ncclGin)</a:t>
             </a:r>
           </a:p>
         </p:txBody>
@@ -4770,7 +4918,7 @@
         <p:spPr>
           <a:xfrm>
             <a:off x="9001125" y="2400300"/>
-            <a:ext cx="0" cy="1104900"/>
+            <a:ext cx="0" cy="285750"/>
           </a:xfrm>
           <a:prstGeom prst="line">
             <a:avLst/>
@@ -4800,48 +4948,107 @@
       </p:cxnSp>
       <p:sp>
         <p:nvSpPr>
-          <p:cNvPr id="17" name="TextBox 16"/>
-          <p:cNvSpPr txBox="1"/>
+          <p:cNvPr id="17" name="Rounded Rectangle 16"/>
+          <p:cNvSpPr/>
           <p:nvPr/>
         </p:nvSpPr>
         <p:spPr>
           <a:xfrm>
-            <a:off x="9096375" y="2819400"/>
-            <a:ext cx="2476500" cy="285750"/>
-          </a:xfrm>
-          <a:prstGeom prst="rect">
-            <a:avLst/>
-          </a:prstGeom>
-          <a:noFill/>
-        </p:spPr>
-        <p:txBody>
-          <a:bodyPr wrap="square" lIns="0" rIns="0" tIns="0" bIns="0" anchor="ctr">
-            <a:spAutoFit/>
-          </a:bodyPr>
+            <a:off x="6600825" y="2686050"/>
+            <a:ext cx="4800600" cy="533400"/>
+          </a:xfrm>
+          <a:prstGeom prst="roundRect">
+            <a:avLst>
+              <a:gd name="adj" fmla="val 10000"/>
+            </a:avLst>
+          </a:prstGeom>
+          <a:solidFill>
+            <a:srgbClr val="124022"/>
+          </a:solidFill>
+          <a:ln w="15875">
+            <a:solidFill>
+              <a:srgbClr val="24A046"/>
+            </a:solidFill>
+          </a:ln>
+          <a:effectLst/>
+        </p:spPr>
+        <p:style>
+          <a:lnRef idx="1">
+            <a:schemeClr val="accent1"/>
+          </a:lnRef>
+          <a:fillRef idx="3">
+            <a:schemeClr val="accent1"/>
+          </a:fillRef>
+          <a:effectRef idx="2">
+            <a:schemeClr val="accent1"/>
+          </a:effectRef>
+          <a:fontRef idx="minor">
+            <a:schemeClr val="lt1"/>
+          </a:fontRef>
+        </p:style>
+        <p:txBody>
+          <a:bodyPr rtlCol="0" anchor="ctr" wrap="square" lIns="19050" rIns="19050" tIns="19050" bIns="19050"/>
           <a:lstStyle/>
           <a:p>
-            <a:pPr algn="l">
+            <a:pPr algn="ctr">
               <a:lnSpc>
                 <a:spcPct val="122000"/>
               </a:lnSpc>
             </a:pPr>
             <a:r>
-              <a:rPr sz="1300" b="0">
+              <a:rPr sz="1500" b="1">
                 <a:solidFill>
-                  <a:srgbClr val="3BD16F"/>
+                  <a:srgbClr val="F5F5F8"/>
                 </a:solidFill>
                 <a:latin typeface="Amazon Ember"/>
                 <a:ea typeface="メイリオ"/>
                 <a:cs typeface="メイリオ"/>
               </a:rPr>
-              <a:t>auto-selected where supported</a:t>
-            </a:r>
-          </a:p>
-        </p:txBody>
-      </p:sp>
-      <p:sp>
-        <p:nvSpPr>
-          <p:cNvPr id="18" name="Rounded Rectangle 17"/>
+              <a:t>efa-dp-direct (inside NCCL)</a:t>
+            </a:r>
+          </a:p>
+        </p:txBody>
+      </p:sp>
+      <p:cxnSp>
+        <p:nvCxnSpPr>
+          <p:cNvPr id="18" name="Connector 17"/>
+          <p:cNvCxnSpPr/>
+          <p:nvPr/>
+        </p:nvCxnSpPr>
+        <p:spPr>
+          <a:xfrm>
+            <a:off x="9001125" y="3219450"/>
+            <a:ext cx="0" cy="285750"/>
+          </a:xfrm>
+          <a:prstGeom prst="line">
+            <a:avLst/>
+          </a:prstGeom>
+          <a:ln w="25400">
+            <a:solidFill>
+              <a:srgbClr val="F5F5F8"/>
+            </a:solidFill>
+            <a:tailEnd type="triangle" w="med" len="med"/>
+          </a:ln>
+          <a:effectLst/>
+        </p:spPr>
+        <p:style>
+          <a:lnRef idx="2">
+            <a:schemeClr val="accent1"/>
+          </a:lnRef>
+          <a:fillRef idx="0">
+            <a:schemeClr val="accent1"/>
+          </a:fillRef>
+          <a:effectRef idx="1">
+            <a:schemeClr val="accent1"/>
+          </a:effectRef>
+          <a:fontRef idx="minor">
+            <a:schemeClr val="tx1"/>
+          </a:fontRef>
+        </p:style>
+      </p:cxnSp>
+      <p:sp>
+        <p:nvSpPr>
+          <p:cNvPr id="19" name="Rounded Rectangle 18"/>
           <p:cNvSpPr/>
           <p:nvPr/>
         </p:nvSpPr>
@@ -4898,146 +5105,6 @@
                 <a:cs typeface="メイリオ"/>
               </a:rPr>
               <a:t>EFA (SRD)</a:t>
-            </a:r>
-          </a:p>
-        </p:txBody>
-      </p:sp>
-      <p:sp>
-        <p:nvSpPr>
-          <p:cNvPr id="19" name="Rounded Rectangle 18"/>
-          <p:cNvSpPr/>
-          <p:nvPr/>
-        </p:nvSpPr>
-        <p:spPr>
-          <a:xfrm>
-            <a:off x="6219825" y="4724400"/>
-            <a:ext cx="5562600" cy="1047750"/>
-          </a:xfrm>
-          <a:prstGeom prst="roundRect">
-            <a:avLst>
-              <a:gd name="adj" fmla="val 10000"/>
-            </a:avLst>
-          </a:prstGeom>
-          <a:solidFill>
-            <a:srgbClr val="161A1E"/>
-          </a:solidFill>
-          <a:ln w="15875">
-            <a:solidFill>
-              <a:srgbClr val="96969E"/>
-            </a:solidFill>
-          </a:ln>
-          <a:effectLst/>
-        </p:spPr>
-        <p:style>
-          <a:lnRef idx="1">
-            <a:schemeClr val="accent1"/>
-          </a:lnRef>
-          <a:fillRef idx="3">
-            <a:schemeClr val="accent1"/>
-          </a:fillRef>
-          <a:effectRef idx="2">
-            <a:schemeClr val="accent1"/>
-          </a:effectRef>
-          <a:fontRef idx="minor">
-            <a:schemeClr val="lt1"/>
-          </a:fontRef>
-        </p:style>
-        <p:txBody>
-          <a:bodyPr rtlCol="0" anchor="ctr" wrap="square" lIns="19050" rIns="19050" tIns="19050" bIns="19050"/>
-          <a:lstStyle/>
-          <a:p>
-            <a:pPr algn="ctr">
-              <a:lnSpc>
-                <a:spcPct val="122000"/>
-              </a:lnSpc>
-            </a:pPr>
-            <a:r>
-              <a:rPr sz="1400" b="1">
-                <a:solidFill>
-                  <a:srgbClr val="96969E"/>
-                </a:solidFill>
-                <a:latin typeface="Amazon Ember"/>
-                <a:ea typeface="メイリオ"/>
-                <a:cs typeface="メイリオ"/>
-              </a:rPr>
-              <a:t>NCCL 2.31.2+, GDRCopy 2.5+ (both modes)</a:t>
-            </a:r>
-          </a:p>
-          <a:p>
-            <a:pPr algn="ctr">
-              <a:lnSpc>
-                <a:spcPct val="122000"/>
-              </a:lnSpc>
-            </a:pPr>
-            <a:r>
-              <a:rPr sz="1400" b="1">
-                <a:solidFill>
-                  <a:srgbClr val="96969E"/>
-                </a:solidFill>
-                <a:latin typeface="Amazon Ember"/>
-                <a:ea typeface="メイリオ"/>
-                <a:cs typeface="メイリオ"/>
-              </a:rPr>
-              <a:t>kernel backend: Libfabric 2.6.0+,</a:t>
-            </a:r>
-          </a:p>
-          <a:p>
-            <a:pPr algn="ctr">
-              <a:lnSpc>
-                <a:spcPct val="122000"/>
-              </a:lnSpc>
-            </a:pPr>
-            <a:r>
-              <a:rPr sz="1400" b="1">
-                <a:solidFill>
-                  <a:srgbClr val="96969E"/>
-                </a:solidFill>
-                <a:latin typeface="Amazon Ember"/>
-                <a:ea typeface="メイリオ"/>
-                <a:cs typeface="メイリオ"/>
-              </a:rPr>
-              <a:t>supported EFA instance type</a:t>
-            </a:r>
-          </a:p>
-        </p:txBody>
-      </p:sp>
-      <p:sp>
-        <p:nvSpPr>
-          <p:cNvPr id="20" name="TextBox 19"/>
-          <p:cNvSpPr txBox="1"/>
-          <p:nvPr/>
-        </p:nvSpPr>
-        <p:spPr>
-          <a:xfrm>
-            <a:off x="409575" y="5334000"/>
-            <a:ext cx="11334750" cy="285750"/>
-          </a:xfrm>
-          <a:prstGeom prst="rect">
-            <a:avLst/>
-          </a:prstGeom>
-          <a:noFill/>
-        </p:spPr>
-        <p:txBody>
-          <a:bodyPr wrap="square" lIns="0" rIns="0" tIns="0" bIns="0" anchor="ctr">
-            <a:spAutoFit/>
-          </a:bodyPr>
-          <a:lstStyle/>
-          <a:p>
-            <a:pPr algn="l">
-              <a:lnSpc>
-                <a:spcPct val="122000"/>
-              </a:lnSpc>
-            </a:pPr>
-            <a:r>
-              <a:rPr sz="1300" b="0">
-                <a:solidFill>
-                  <a:srgbClr val="96969E"/>
-                </a:solidFill>
-                <a:latin typeface="Amazon Ember"/>
-                <a:ea typeface="メイリオ"/>
-                <a:cs typeface="メイリオ"/>
-              </a:rPr>
-              <a:t>Per aws-ofi-nccl v1.21.0 and NCCL 2.31.2 release notes</a:t>
             </a:r>
           </a:p>
         </p:txBody>

</xml_diff>